<commit_message>
Update user flow diagram - fixes #212
</commit_message>
<xml_diff>
--- a/docs/img/icds_docs_images.pptx
+++ b/docs/img/icds_docs_images.pptx
@@ -208,7 +208,7 @@
           <a:p>
             <a:fld id="{8F25345D-83D0-4643-B4BC-44C238B5A8CF}" type="datetimeFigureOut">
               <a:rPr lang="en-US" smtClean="0"/>
-              <a:t>12/19/25</a:t>
+              <a:t>2/19/26</a:t>
             </a:fld>
             <a:endParaRPr lang="en-US"/>
           </a:p>
@@ -790,7 +790,7 @@
           <a:p>
             <a:fld id="{06F6D09A-9F42-C649-A6EB-DC34432B03F0}" type="datetimeFigureOut">
               <a:rPr lang="en-US" smtClean="0"/>
-              <a:t>12/19/25</a:t>
+              <a:t>2/19/26</a:t>
             </a:fld>
             <a:endParaRPr lang="en-US"/>
           </a:p>
@@ -988,7 +988,7 @@
           <a:p>
             <a:fld id="{06F6D09A-9F42-C649-A6EB-DC34432B03F0}" type="datetimeFigureOut">
               <a:rPr lang="en-US" smtClean="0"/>
-              <a:t>12/19/25</a:t>
+              <a:t>2/19/26</a:t>
             </a:fld>
             <a:endParaRPr lang="en-US"/>
           </a:p>
@@ -1196,7 +1196,7 @@
           <a:p>
             <a:fld id="{06F6D09A-9F42-C649-A6EB-DC34432B03F0}" type="datetimeFigureOut">
               <a:rPr lang="en-US" smtClean="0"/>
-              <a:t>12/19/25</a:t>
+              <a:t>2/19/26</a:t>
             </a:fld>
             <a:endParaRPr lang="en-US"/>
           </a:p>
@@ -1394,7 +1394,7 @@
           <a:p>
             <a:fld id="{06F6D09A-9F42-C649-A6EB-DC34432B03F0}" type="datetimeFigureOut">
               <a:rPr lang="en-US" smtClean="0"/>
-              <a:t>12/19/25</a:t>
+              <a:t>2/19/26</a:t>
             </a:fld>
             <a:endParaRPr lang="en-US"/>
           </a:p>
@@ -1669,7 +1669,7 @@
           <a:p>
             <a:fld id="{06F6D09A-9F42-C649-A6EB-DC34432B03F0}" type="datetimeFigureOut">
               <a:rPr lang="en-US" smtClean="0"/>
-              <a:t>12/19/25</a:t>
+              <a:t>2/19/26</a:t>
             </a:fld>
             <a:endParaRPr lang="en-US"/>
           </a:p>
@@ -1934,7 +1934,7 @@
           <a:p>
             <a:fld id="{06F6D09A-9F42-C649-A6EB-DC34432B03F0}" type="datetimeFigureOut">
               <a:rPr lang="en-US" smtClean="0"/>
-              <a:t>12/19/25</a:t>
+              <a:t>2/19/26</a:t>
             </a:fld>
             <a:endParaRPr lang="en-US"/>
           </a:p>
@@ -2346,7 +2346,7 @@
           <a:p>
             <a:fld id="{06F6D09A-9F42-C649-A6EB-DC34432B03F0}" type="datetimeFigureOut">
               <a:rPr lang="en-US" smtClean="0"/>
-              <a:t>12/19/25</a:t>
+              <a:t>2/19/26</a:t>
             </a:fld>
             <a:endParaRPr lang="en-US"/>
           </a:p>
@@ -2487,7 +2487,7 @@
           <a:p>
             <a:fld id="{06F6D09A-9F42-C649-A6EB-DC34432B03F0}" type="datetimeFigureOut">
               <a:rPr lang="en-US" smtClean="0"/>
-              <a:t>12/19/25</a:t>
+              <a:t>2/19/26</a:t>
             </a:fld>
             <a:endParaRPr lang="en-US"/>
           </a:p>
@@ -2600,7 +2600,7 @@
           <a:p>
             <a:fld id="{06F6D09A-9F42-C649-A6EB-DC34432B03F0}" type="datetimeFigureOut">
               <a:rPr lang="en-US" smtClean="0"/>
-              <a:t>12/19/25</a:t>
+              <a:t>2/19/26</a:t>
             </a:fld>
             <a:endParaRPr lang="en-US"/>
           </a:p>
@@ -2911,7 +2911,7 @@
           <a:p>
             <a:fld id="{06F6D09A-9F42-C649-A6EB-DC34432B03F0}" type="datetimeFigureOut">
               <a:rPr lang="en-US" smtClean="0"/>
-              <a:t>12/19/25</a:t>
+              <a:t>2/19/26</a:t>
             </a:fld>
             <a:endParaRPr lang="en-US"/>
           </a:p>
@@ -3203,7 +3203,7 @@
           <a:p>
             <a:fld id="{06F6D09A-9F42-C649-A6EB-DC34432B03F0}" type="datetimeFigureOut">
               <a:rPr lang="en-US" smtClean="0"/>
-              <a:t>12/19/25</a:t>
+              <a:t>2/19/26</a:t>
             </a:fld>
             <a:endParaRPr lang="en-US"/>
           </a:p>
@@ -3444,7 +3444,7 @@
           <a:p>
             <a:fld id="{06F6D09A-9F42-C649-A6EB-DC34432B03F0}" type="datetimeFigureOut">
               <a:rPr lang="en-US" smtClean="0"/>
-              <a:t>12/19/25</a:t>
+              <a:t>2/19/26</a:t>
             </a:fld>
             <a:endParaRPr lang="en-US"/>
           </a:p>
@@ -11215,6 +11215,15 @@
 </file>
 
 <file path=customXml/item1.xml><?xml version="1.0" encoding="utf-8"?>
+<?mso-contentType ?>
+<FormTemplates xmlns="http://schemas.microsoft.com/sharepoint/v3/contenttype/forms">
+  <Display>DocumentLibraryForm</Display>
+  <Edit>DocumentLibraryForm</Edit>
+  <New>DocumentLibraryForm</New>
+</FormTemplates>
+</file>
+
+<file path=customXml/item2.xml><?xml version="1.0" encoding="utf-8"?>
 <ct:contentTypeSchema xmlns:ct="http://schemas.microsoft.com/office/2006/metadata/contentType" xmlns:ma="http://schemas.microsoft.com/office/2006/metadata/properties/metaAttributes" ct:_="" ma:_="" ma:contentTypeName="Document" ma:contentTypeID="0x010100E843CC197C4EA6429DB8706FA366B0A9" ma:contentTypeVersion="16" ma:contentTypeDescription="Create a new document." ma:contentTypeScope="" ma:versionID="b4700a85abd1a74edb701ca6d3afdd96">
   <xsd:schema xmlns:xsd="http://www.w3.org/2001/XMLSchema" xmlns:xs="http://www.w3.org/2001/XMLSchema" xmlns:p="http://schemas.microsoft.com/office/2006/metadata/properties" xmlns:ns2="4b28dc4c-da69-43c9-a1ff-3a3813db799e" xmlns:ns3="23ad9178-ade2-434f-a880-cfaf139256ed" targetNamespace="http://schemas.microsoft.com/office/2006/metadata/properties" ma:root="true" ma:fieldsID="19eeb97119fa32ac520f06cf83d0de92" ns2:_="" ns3:_="">
     <xsd:import namespace="4b28dc4c-da69-43c9-a1ff-3a3813db799e"/>
@@ -11457,15 +11466,6 @@
 </ct:contentTypeSchema>
 </file>
 
-<file path=customXml/item2.xml><?xml version="1.0" encoding="utf-8"?>
-<?mso-contentType ?>
-<FormTemplates xmlns="http://schemas.microsoft.com/sharepoint/v3/contenttype/forms">
-  <Display>DocumentLibraryForm</Display>
-  <Edit>DocumentLibraryForm</Edit>
-  <New>DocumentLibraryForm</New>
-</FormTemplates>
-</file>
-
 <file path=customXml/item3.xml><?xml version="1.0" encoding="utf-8"?>
 <p:properties xmlns:p="http://schemas.microsoft.com/office/2006/metadata/properties" xmlns:xsi="http://www.w3.org/2001/XMLSchema-instance" xmlns:pc="http://schemas.microsoft.com/office/infopath/2007/PartnerControls">
   <documentManagement>
@@ -11505,6 +11505,14 @@
 </file>
 
 <file path=customXml/itemProps1.xml><?xml version="1.0" encoding="utf-8"?>
+<ds:datastoreItem xmlns:ds="http://schemas.openxmlformats.org/officeDocument/2006/customXml" ds:itemID="{74FE70FB-0FCE-428C-BA58-AD39043535D1}">
+  <ds:schemaRefs>
+    <ds:schemaRef ds:uri="http://schemas.microsoft.com/sharepoint/v3/contenttype/forms"/>
+  </ds:schemaRefs>
+</ds:datastoreItem>
+</file>
+
+<file path=customXml/itemProps2.xml><?xml version="1.0" encoding="utf-8"?>
 <ds:datastoreItem xmlns:ds="http://schemas.openxmlformats.org/officeDocument/2006/customXml" ds:itemID="{8DC5FBCA-8CEE-41E9-8E12-E7355B00A1CC}">
   <ds:schemaRefs>
     <ds:schemaRef ds:uri="http://schemas.microsoft.com/office/2006/metadata/contentType"/>
@@ -11519,14 +11527,6 @@
     <ds:schemaRef ds:uri="http://purl.org/dc/elements/1.1/"/>
     <ds:schemaRef ds:uri="http://purl.org/dc/terms/"/>
     <ds:schemaRef ds:uri="http://schemas.microsoft.com/internal/obd"/>
-  </ds:schemaRefs>
-</ds:datastoreItem>
-</file>
-
-<file path=customXml/itemProps2.xml><?xml version="1.0" encoding="utf-8"?>
-<ds:datastoreItem xmlns:ds="http://schemas.openxmlformats.org/officeDocument/2006/customXml" ds:itemID="{74FE70FB-0FCE-428C-BA58-AD39043535D1}">
-  <ds:schemaRefs>
-    <ds:schemaRef ds:uri="http://schemas.microsoft.com/sharepoint/v3/contenttype/forms"/>
   </ds:schemaRefs>
 </ds:datastoreItem>
 </file>

</xml_diff>